<commit_message>
Regenerate PowerPoint for song #3 in fubc-ua
</commit_message>
<xml_diff>
--- a/fubc-ua/3-Благо Cлавити Господа.pptx
+++ b/fubc-ua/3-Благо Cлавити Господа.pptx
@@ -11,9 +11,10 @@
     <p:sldId id="259" r:id="rId5"/>
     <p:sldId id="260" r:id="rId6"/>
     <p:sldId id="261" r:id="rId7"/>
+    <p:sldId id="262" r:id="rId8"/>
   </p:sldIdLst>
   <p:notesMasterIdLst>
-    <p:notesMasterId r:id="rId8"/>
+    <p:notesMasterId r:id="rId9"/>
   </p:notesMasterIdLst>
   <p:sldSz cx="12192000" cy="6858000"/>
   <p:notesSz cx="6858000" cy="12192000"/>
@@ -971,6 +972,94 @@
             <a:fld id="{F7021451-1387-4CA6-816F-3879F97B5CBC}" type="slidenum">
               <a:rPr lang="en-US"/>
               <a:t>6</a:t>
+            </a:fld>
+            <a:endParaRPr lang="en-US"/>
+          </a:p>
+        </p:txBody>
+      </p:sp>
+    </p:spTree>
+    <p:extLst>
+      <p:ext uri="{BB962C8B-B14F-4D97-AF65-F5344CB8AC3E}">
+        <p14:creationId xmlns:p14="http://schemas.microsoft.com/office/powerpoint/2010/main" val="1024086991"/>
+      </p:ext>
+    </p:extLst>
+  </p:cSld>
+  <p:clrMapOvr>
+    <a:masterClrMapping/>
+  </p:clrMapOvr>
+</p:notes>
+</file>
+
+<file path=ppt/notesSlides/notesSlide7.xml><?xml version="1.0" encoding="utf-8"?>
+<p:notes xmlns:a="http://schemas.openxmlformats.org/drawingml/2006/main" xmlns:r="http://schemas.openxmlformats.org/officeDocument/2006/relationships" xmlns:p="http://schemas.openxmlformats.org/presentationml/2006/main">
+  <p:cSld>
+    <p:spTree>
+      <p:nvGrpSpPr>
+        <p:cNvPr id="1" name=""/>
+        <p:cNvGrpSpPr/>
+        <p:nvPr/>
+      </p:nvGrpSpPr>
+      <p:grpSpPr>
+        <a:xfrm>
+          <a:off x="0" y="0"/>
+          <a:ext cx="0" cy="0"/>
+          <a:chOff x="0" y="0"/>
+          <a:chExt cx="0" cy="0"/>
+        </a:xfrm>
+      </p:grpSpPr>
+      <p:sp>
+        <p:nvSpPr>
+          <p:cNvPr id="2" name="Slide Image Placeholder 1"/>
+          <p:cNvSpPr>
+            <a:spLocks noGrp="1" noRot="1" noChangeAspect="1"/>
+          </p:cNvSpPr>
+          <p:nvPr>
+            <p:ph type="sldImg"/>
+          </p:nvPr>
+        </p:nvSpPr>
+        <p:spPr/>
+      </p:sp>
+      <p:sp>
+        <p:nvSpPr>
+          <p:cNvPr id="3" name="Notes Placeholder 2"/>
+          <p:cNvSpPr>
+            <a:spLocks noGrp="1"/>
+          </p:cNvSpPr>
+          <p:nvPr>
+            <p:ph type="body" idx="1"/>
+          </p:nvPr>
+        </p:nvSpPr>
+        <p:spPr/>
+        <p:txBody>
+          <a:bodyPr/>
+          <a:lstStyle/>
+          <a:p>
+            <a:r>
+              <a:rPr lang="en-US" dirty="0"/>
+              <a:t/>
+            </a:r>
+            <a:endParaRPr lang="en-US" dirty="0"/>
+          </a:p>
+        </p:txBody>
+      </p:sp>
+      <p:sp>
+        <p:nvSpPr>
+          <p:cNvPr id="4" name="Slide Number Placeholder 3"/>
+          <p:cNvSpPr>
+            <a:spLocks noGrp="1"/>
+          </p:cNvSpPr>
+          <p:nvPr>
+            <p:ph type="sldNum" sz="quarter" idx="10"/>
+          </p:nvPr>
+        </p:nvSpPr>
+        <p:spPr/>
+        <p:txBody>
+          <a:bodyPr/>
+          <a:lstStyle/>
+          <a:p>
+            <a:fld id="{F7021451-1387-4CA6-816F-3879F97B5CBC}" type="slidenum">
+              <a:rPr lang="en-US"/>
+              <a:t>7</a:t>
             </a:fld>
             <a:endParaRPr lang="en-US"/>
           </a:p>
@@ -1345,7 +1434,7 @@
               <a:buNone/>
             </a:pPr>
             <a:r>
-              <a:rPr lang="en-US" sz="4000" b="1" dirty="0">
+              <a:rPr lang="en-US" sz="4800" b="1" dirty="0">
                 <a:solidFill>
                   <a:srgbClr val="FFFFFF"/>
                 </a:solidFill>
@@ -1353,60 +1442,9 @@
                 <a:ea typeface="Arial" pitchFamily="34" charset="-122"/>
                 <a:cs typeface="Arial" pitchFamily="34" charset="-120"/>
               </a:rPr>
-              <a:t>Благо славити Господа,</a:t>
-            </a:r>
-            <a:endParaRPr lang="en-US" sz="4000" dirty="0"/>
-          </a:p>
-          <a:p>
-            <a:pPr algn="ctr" indent="0" marL="0">
-              <a:buNone/>
-            </a:pPr>
-            <a:r>
-              <a:rPr lang="en-US" sz="4000" b="1" dirty="0">
-                <a:solidFill>
-                  <a:srgbClr val="FFFFFF"/>
-                </a:solidFill>
-                <a:latin typeface="Arial" pitchFamily="34" charset="0"/>
-                <a:ea typeface="Arial" pitchFamily="34" charset="-122"/>
-                <a:cs typeface="Arial" pitchFamily="34" charset="-120"/>
-              </a:rPr>
-              <a:t>оспівувати Твоє Ім'я</a:t>
-            </a:r>
-            <a:endParaRPr lang="en-US" sz="4000" dirty="0"/>
-          </a:p>
-          <a:p>
-            <a:pPr algn="ctr" indent="0" marL="0">
-              <a:buNone/>
-            </a:pPr>
-            <a:r>
-              <a:rPr lang="en-US" sz="4000" b="1" dirty="0">
-                <a:solidFill>
-                  <a:srgbClr val="FFFFFF"/>
-                </a:solidFill>
-                <a:latin typeface="Arial" pitchFamily="34" charset="0"/>
-                <a:ea typeface="Arial" pitchFamily="34" charset="-122"/>
-                <a:cs typeface="Arial" pitchFamily="34" charset="-120"/>
-              </a:rPr>
-              <a:t>Ранком милість звіщати Твою,</a:t>
-            </a:r>
-            <a:endParaRPr lang="en-US" sz="4000" dirty="0"/>
-          </a:p>
-          <a:p>
-            <a:pPr algn="ctr" indent="0" marL="0">
-              <a:buNone/>
-            </a:pPr>
-            <a:r>
-              <a:rPr lang="en-US" sz="4000" b="1" dirty="0">
-                <a:solidFill>
-                  <a:srgbClr val="FFFFFF"/>
-                </a:solidFill>
-                <a:latin typeface="Arial" pitchFamily="34" charset="0"/>
-                <a:ea typeface="Arial" pitchFamily="34" charset="-122"/>
-                <a:cs typeface="Arial" pitchFamily="34" charset="-120"/>
-              </a:rPr>
-              <a:t>і істину Твою вночі.</a:t>
-            </a:r>
-            <a:endParaRPr lang="en-US" sz="4000" dirty="0"/>
+              <a:t>Благо Cлавити Господа</a:t>
+            </a:r>
+            <a:endParaRPr lang="en-US" sz="4800" dirty="0"/>
           </a:p>
         </p:txBody>
       </p:sp>
@@ -1467,7 +1505,7 @@
               <a:buNone/>
             </a:pPr>
             <a:r>
-              <a:rPr lang="en-US" sz="4000" b="1" i="1" dirty="0">
+              <a:rPr lang="en-US" sz="4800" b="1" dirty="0">
                 <a:solidFill>
                   <a:srgbClr val="FFFFFF"/>
                 </a:solidFill>
@@ -1475,16 +1513,16 @@
                 <a:ea typeface="Arial" pitchFamily="34" charset="-122"/>
                 <a:cs typeface="Arial" pitchFamily="34" charset="-120"/>
               </a:rPr>
-              <a:t>Ти розвеселив душу мою,</a:t>
-            </a:r>
-            <a:endParaRPr lang="en-US" sz="4000" dirty="0"/>
+              <a:t>Благо славити Господа,</a:t>
+            </a:r>
+            <a:endParaRPr lang="en-US" sz="4800" dirty="0"/>
           </a:p>
           <a:p>
             <a:pPr algn="ctr" indent="0" marL="0">
               <a:buNone/>
             </a:pPr>
             <a:r>
-              <a:rPr lang="en-US" sz="4000" b="1" i="1" dirty="0">
+              <a:rPr lang="en-US" sz="4800" b="1" dirty="0">
                 <a:solidFill>
                   <a:srgbClr val="FFFFFF"/>
                 </a:solidFill>
@@ -1492,16 +1530,16 @@
                 <a:ea typeface="Arial" pitchFamily="34" charset="-122"/>
                 <a:cs typeface="Arial" pitchFamily="34" charset="-120"/>
               </a:rPr>
-              <a:t>Я Тобі Господь хвалу даю</a:t>
-            </a:r>
-            <a:endParaRPr lang="en-US" sz="4000" dirty="0"/>
+              <a:t>оспівувати Твоє Ім'я</a:t>
+            </a:r>
+            <a:endParaRPr lang="en-US" sz="4800" dirty="0"/>
           </a:p>
           <a:p>
             <a:pPr algn="ctr" indent="0" marL="0">
               <a:buNone/>
             </a:pPr>
             <a:r>
-              <a:rPr lang="en-US" sz="4000" b="1" i="1" dirty="0">
+              <a:rPr lang="en-US" sz="4800" b="1" dirty="0">
                 <a:solidFill>
                   <a:srgbClr val="FFFFFF"/>
                 </a:solidFill>
@@ -1509,16 +1547,16 @@
                 <a:ea typeface="Arial" pitchFamily="34" charset="-122"/>
                 <a:cs typeface="Arial" pitchFamily="34" charset="-120"/>
               </a:rPr>
-              <a:t>Діла Твої великі, мій Отець,</a:t>
-            </a:r>
-            <a:endParaRPr lang="en-US" sz="4000" dirty="0"/>
+              <a:t>Ранком милість звіщати Твою,</a:t>
+            </a:r>
+            <a:endParaRPr lang="en-US" sz="4800" dirty="0"/>
           </a:p>
           <a:p>
             <a:pPr algn="ctr" indent="0" marL="0">
               <a:buNone/>
             </a:pPr>
             <a:r>
-              <a:rPr lang="en-US" sz="4000" b="1" i="1" dirty="0">
+              <a:rPr lang="en-US" sz="4800" b="1" dirty="0">
                 <a:solidFill>
                   <a:srgbClr val="FFFFFF"/>
                 </a:solidFill>
@@ -1526,9 +1564,9 @@
                 <a:ea typeface="Arial" pitchFamily="34" charset="-122"/>
                 <a:cs typeface="Arial" pitchFamily="34" charset="-120"/>
               </a:rPr>
-              <a:t>Ти - мій Творець (Ти - мій Творець)</a:t>
-            </a:r>
-            <a:endParaRPr lang="en-US" sz="4000" dirty="0"/>
+              <a:t>і істину Твою вночі.</a:t>
+            </a:r>
+            <a:endParaRPr lang="en-US" sz="4800" dirty="0"/>
           </a:p>
         </p:txBody>
       </p:sp>
@@ -1589,7 +1627,7 @@
               <a:buNone/>
             </a:pPr>
             <a:r>
-              <a:rPr lang="en-US" sz="4000" b="1" dirty="0">
+              <a:rPr lang="en-US" sz="4800" b="1" i="1" dirty="0">
                 <a:solidFill>
                   <a:srgbClr val="FFFFFF"/>
                 </a:solidFill>
@@ -1597,16 +1635,16 @@
                 <a:ea typeface="Arial" pitchFamily="34" charset="-122"/>
                 <a:cs typeface="Arial" pitchFamily="34" charset="-120"/>
               </a:rPr>
-              <a:t>Підведу свої очі до гір,</a:t>
-            </a:r>
-            <a:endParaRPr lang="en-US" sz="4000" dirty="0"/>
+              <a:t>Ти розвеселив душу мою,</a:t>
+            </a:r>
+            <a:endParaRPr lang="en-US" sz="4800" dirty="0"/>
           </a:p>
           <a:p>
             <a:pPr algn="ctr" indent="0" marL="0">
               <a:buNone/>
             </a:pPr>
             <a:r>
-              <a:rPr lang="en-US" sz="4000" b="1" dirty="0">
+              <a:rPr lang="en-US" sz="4800" b="1" i="1" dirty="0">
                 <a:solidFill>
                   <a:srgbClr val="FFFFFF"/>
                 </a:solidFill>
@@ -1614,16 +1652,16 @@
                 <a:ea typeface="Arial" pitchFamily="34" charset="-122"/>
                 <a:cs typeface="Arial" pitchFamily="34" charset="-120"/>
               </a:rPr>
-              <a:t>підніму свої руки в небо.</a:t>
-            </a:r>
-            <a:endParaRPr lang="en-US" sz="4000" dirty="0"/>
+              <a:t>Я Тобі Господь хвалу даю</a:t>
+            </a:r>
+            <a:endParaRPr lang="en-US" sz="4800" dirty="0"/>
           </a:p>
           <a:p>
             <a:pPr algn="ctr" indent="0" marL="0">
               <a:buNone/>
             </a:pPr>
             <a:r>
-              <a:rPr lang="en-US" sz="4000" b="1" dirty="0">
+              <a:rPr lang="en-US" sz="4800" b="1" i="1" dirty="0">
                 <a:solidFill>
                   <a:srgbClr val="FFFFFF"/>
                 </a:solidFill>
@@ -1631,16 +1669,16 @@
                 <a:ea typeface="Arial" pitchFamily="34" charset="-122"/>
                 <a:cs typeface="Arial" pitchFamily="34" charset="-120"/>
               </a:rPr>
-              <a:t>Знаю я - Ти Господь Святий ,</a:t>
-            </a:r>
-            <a:endParaRPr lang="en-US" sz="4000" dirty="0"/>
+              <a:t>Діла Твої великі, мій Отець,</a:t>
+            </a:r>
+            <a:endParaRPr lang="en-US" sz="4800" dirty="0"/>
           </a:p>
           <a:p>
             <a:pPr algn="ctr" indent="0" marL="0">
               <a:buNone/>
             </a:pPr>
             <a:r>
-              <a:rPr lang="en-US" sz="4000" b="1" dirty="0">
+              <a:rPr lang="en-US" sz="4800" b="1" i="1" dirty="0">
                 <a:solidFill>
                   <a:srgbClr val="FFFFFF"/>
                 </a:solidFill>
@@ -1648,9 +1686,9 @@
                 <a:ea typeface="Arial" pitchFamily="34" charset="-122"/>
                 <a:cs typeface="Arial" pitchFamily="34" charset="-120"/>
               </a:rPr>
-              <a:t>і над землею вище всіх.</a:t>
-            </a:r>
-            <a:endParaRPr lang="en-US" sz="4000" dirty="0"/>
+              <a:t>Ти - мій Творець (Ти - мій Творець)</a:t>
+            </a:r>
+            <a:endParaRPr lang="en-US" sz="4800" dirty="0"/>
           </a:p>
         </p:txBody>
       </p:sp>
@@ -1711,7 +1749,7 @@
               <a:buNone/>
             </a:pPr>
             <a:r>
-              <a:rPr lang="en-US" sz="4000" b="1" i="1" dirty="0">
+              <a:rPr lang="en-US" sz="4800" b="1" dirty="0">
                 <a:solidFill>
                   <a:srgbClr val="FFFFFF"/>
                 </a:solidFill>
@@ -1719,16 +1757,16 @@
                 <a:ea typeface="Arial" pitchFamily="34" charset="-122"/>
                 <a:cs typeface="Arial" pitchFamily="34" charset="-120"/>
               </a:rPr>
-              <a:t>Ти розвеселив душу мою,</a:t>
-            </a:r>
-            <a:endParaRPr lang="en-US" sz="4000" dirty="0"/>
+              <a:t>Підведу свої очі до гір,</a:t>
+            </a:r>
+            <a:endParaRPr lang="en-US" sz="4800" dirty="0"/>
           </a:p>
           <a:p>
             <a:pPr algn="ctr" indent="0" marL="0">
               <a:buNone/>
             </a:pPr>
             <a:r>
-              <a:rPr lang="en-US" sz="4000" b="1" i="1" dirty="0">
+              <a:rPr lang="en-US" sz="4800" b="1" dirty="0">
                 <a:solidFill>
                   <a:srgbClr val="FFFFFF"/>
                 </a:solidFill>
@@ -1736,16 +1774,16 @@
                 <a:ea typeface="Arial" pitchFamily="34" charset="-122"/>
                 <a:cs typeface="Arial" pitchFamily="34" charset="-120"/>
               </a:rPr>
-              <a:t>Я Тобі Господь хвалу даю</a:t>
-            </a:r>
-            <a:endParaRPr lang="en-US" sz="4000" dirty="0"/>
+              <a:t>підніму свої руки в небо.</a:t>
+            </a:r>
+            <a:endParaRPr lang="en-US" sz="4800" dirty="0"/>
           </a:p>
           <a:p>
             <a:pPr algn="ctr" indent="0" marL="0">
               <a:buNone/>
             </a:pPr>
             <a:r>
-              <a:rPr lang="en-US" sz="4000" b="1" i="1" dirty="0">
+              <a:rPr lang="en-US" sz="4800" b="1" dirty="0">
                 <a:solidFill>
                   <a:srgbClr val="FFFFFF"/>
                 </a:solidFill>
@@ -1753,16 +1791,16 @@
                 <a:ea typeface="Arial" pitchFamily="34" charset="-122"/>
                 <a:cs typeface="Arial" pitchFamily="34" charset="-120"/>
               </a:rPr>
-              <a:t>Діла Твої великі, мій Отець,</a:t>
-            </a:r>
-            <a:endParaRPr lang="en-US" sz="4000" dirty="0"/>
+              <a:t>Знаю я - Ти Господь Святий ,</a:t>
+            </a:r>
+            <a:endParaRPr lang="en-US" sz="4800" dirty="0"/>
           </a:p>
           <a:p>
             <a:pPr algn="ctr" indent="0" marL="0">
               <a:buNone/>
             </a:pPr>
             <a:r>
-              <a:rPr lang="en-US" sz="4000" b="1" i="1" dirty="0">
+              <a:rPr lang="en-US" sz="4800" b="1" dirty="0">
                 <a:solidFill>
                   <a:srgbClr val="FFFFFF"/>
                 </a:solidFill>
@@ -1770,9 +1808,9 @@
                 <a:ea typeface="Arial" pitchFamily="34" charset="-122"/>
                 <a:cs typeface="Arial" pitchFamily="34" charset="-120"/>
               </a:rPr>
-              <a:t>Ти - мій Творець (Ти - мій Творець)</a:t>
-            </a:r>
-            <a:endParaRPr lang="en-US" sz="4000" dirty="0"/>
+              <a:t>і над землею вище всіх.</a:t>
+            </a:r>
+            <a:endParaRPr lang="en-US" sz="4800" dirty="0"/>
           </a:p>
         </p:txBody>
       </p:sp>
@@ -1833,7 +1871,7 @@
               <a:buNone/>
             </a:pPr>
             <a:r>
-              <a:rPr lang="en-US" sz="4000" b="1" dirty="0">
+              <a:rPr lang="en-US" sz="4800" b="1" i="1" dirty="0">
                 <a:solidFill>
                   <a:srgbClr val="FFFFFF"/>
                 </a:solidFill>
@@ -1841,16 +1879,16 @@
                 <a:ea typeface="Arial" pitchFamily="34" charset="-122"/>
                 <a:cs typeface="Arial" pitchFamily="34" charset="-120"/>
               </a:rPr>
-              <a:t>Господи, Охорона моя!</a:t>
-            </a:r>
-            <a:endParaRPr lang="en-US" sz="4000" dirty="0"/>
+              <a:t>Ти розвеселив душу мою,</a:t>
+            </a:r>
+            <a:endParaRPr lang="en-US" sz="4800" dirty="0"/>
           </a:p>
           <a:p>
             <a:pPr algn="ctr" indent="0" marL="0">
               <a:buNone/>
             </a:pPr>
             <a:r>
-              <a:rPr lang="en-US" sz="4000" b="1" dirty="0">
+              <a:rPr lang="en-US" sz="4800" b="1" i="1" dirty="0">
                 <a:solidFill>
                   <a:srgbClr val="FFFFFF"/>
                 </a:solidFill>
@@ -1858,16 +1896,16 @@
                 <a:ea typeface="Arial" pitchFamily="34" charset="-122"/>
                 <a:cs typeface="Arial" pitchFamily="34" charset="-120"/>
               </a:rPr>
-              <a:t>Ти мій Бог і моя Твердиня!</a:t>
-            </a:r>
-            <a:endParaRPr lang="en-US" sz="4000" dirty="0"/>
+              <a:t>Я Тобі Господь хвалу даю</a:t>
+            </a:r>
+            <a:endParaRPr lang="en-US" sz="4800" dirty="0"/>
           </a:p>
           <a:p>
             <a:pPr algn="ctr" indent="0" marL="0">
               <a:buNone/>
             </a:pPr>
             <a:r>
-              <a:rPr lang="en-US" sz="4000" b="1" dirty="0">
+              <a:rPr lang="en-US" sz="4800" b="1" i="1" dirty="0">
                 <a:solidFill>
                   <a:srgbClr val="FFFFFF"/>
                 </a:solidFill>
@@ -1875,16 +1913,16 @@
                 <a:ea typeface="Arial" pitchFamily="34" charset="-122"/>
                 <a:cs typeface="Arial" pitchFamily="34" charset="-120"/>
               </a:rPr>
-              <a:t>Над землею в святих небесах -</a:t>
-            </a:r>
-            <a:endParaRPr lang="en-US" sz="4000" dirty="0"/>
+              <a:t>Діла Твої великі, мій Отець,</a:t>
+            </a:r>
+            <a:endParaRPr lang="en-US" sz="4800" dirty="0"/>
           </a:p>
           <a:p>
             <a:pPr algn="ctr" indent="0" marL="0">
               <a:buNone/>
             </a:pPr>
             <a:r>
-              <a:rPr lang="en-US" sz="4000" b="1" dirty="0">
+              <a:rPr lang="en-US" sz="4800" b="1" i="1" dirty="0">
                 <a:solidFill>
                   <a:srgbClr val="FFFFFF"/>
                 </a:solidFill>
@@ -1892,9 +1930,9 @@
                 <a:ea typeface="Arial" pitchFamily="34" charset="-122"/>
                 <a:cs typeface="Arial" pitchFamily="34" charset="-120"/>
               </a:rPr>
-              <a:t>cлава Твоя повік віків!</a:t>
-            </a:r>
-            <a:endParaRPr lang="en-US" sz="4000" dirty="0"/>
+              <a:t>Ти - мій Творець (Ти - мій Творець)</a:t>
+            </a:r>
+            <a:endParaRPr lang="en-US" sz="4800" dirty="0"/>
           </a:p>
         </p:txBody>
       </p:sp>
@@ -1955,7 +1993,129 @@
               <a:buNone/>
             </a:pPr>
             <a:r>
-              <a:rPr lang="en-US" sz="4000" b="1" i="1" dirty="0">
+              <a:rPr lang="en-US" sz="4800" b="1" dirty="0">
+                <a:solidFill>
+                  <a:srgbClr val="FFFFFF"/>
+                </a:solidFill>
+                <a:latin typeface="Arial" pitchFamily="34" charset="0"/>
+                <a:ea typeface="Arial" pitchFamily="34" charset="-122"/>
+                <a:cs typeface="Arial" pitchFamily="34" charset="-120"/>
+              </a:rPr>
+              <a:t>Господи, Охорона моя!</a:t>
+            </a:r>
+            <a:endParaRPr lang="en-US" sz="4800" dirty="0"/>
+          </a:p>
+          <a:p>
+            <a:pPr algn="ctr" indent="0" marL="0">
+              <a:buNone/>
+            </a:pPr>
+            <a:r>
+              <a:rPr lang="en-US" sz="4800" b="1" dirty="0">
+                <a:solidFill>
+                  <a:srgbClr val="FFFFFF"/>
+                </a:solidFill>
+                <a:latin typeface="Arial" pitchFamily="34" charset="0"/>
+                <a:ea typeface="Arial" pitchFamily="34" charset="-122"/>
+                <a:cs typeface="Arial" pitchFamily="34" charset="-120"/>
+              </a:rPr>
+              <a:t>Ти мій Бог і моя Твердиня!</a:t>
+            </a:r>
+            <a:endParaRPr lang="en-US" sz="4800" dirty="0"/>
+          </a:p>
+          <a:p>
+            <a:pPr algn="ctr" indent="0" marL="0">
+              <a:buNone/>
+            </a:pPr>
+            <a:r>
+              <a:rPr lang="en-US" sz="4800" b="1" dirty="0">
+                <a:solidFill>
+                  <a:srgbClr val="FFFFFF"/>
+                </a:solidFill>
+                <a:latin typeface="Arial" pitchFamily="34" charset="0"/>
+                <a:ea typeface="Arial" pitchFamily="34" charset="-122"/>
+                <a:cs typeface="Arial" pitchFamily="34" charset="-120"/>
+              </a:rPr>
+              <a:t>Над землею в святих небесах -</a:t>
+            </a:r>
+            <a:endParaRPr lang="en-US" sz="4800" dirty="0"/>
+          </a:p>
+          <a:p>
+            <a:pPr algn="ctr" indent="0" marL="0">
+              <a:buNone/>
+            </a:pPr>
+            <a:r>
+              <a:rPr lang="en-US" sz="4800" b="1" dirty="0">
+                <a:solidFill>
+                  <a:srgbClr val="FFFFFF"/>
+                </a:solidFill>
+                <a:latin typeface="Arial" pitchFamily="34" charset="0"/>
+                <a:ea typeface="Arial" pitchFamily="34" charset="-122"/>
+                <a:cs typeface="Arial" pitchFamily="34" charset="-120"/>
+              </a:rPr>
+              <a:t>cлава Твоя повік віків!</a:t>
+            </a:r>
+            <a:endParaRPr lang="en-US" sz="4800" dirty="0"/>
+          </a:p>
+        </p:txBody>
+      </p:sp>
+    </p:spTree>
+  </p:cSld>
+  <p:clrMapOvr>
+    <a:masterClrMapping/>
+  </p:clrMapOvr>
+</p:sld>
+</file>
+
+<file path=ppt/slides/slide7.xml><?xml version="1.0" encoding="utf-8"?>
+<p:sld xmlns:a="http://schemas.openxmlformats.org/drawingml/2006/main" xmlns:r="http://schemas.openxmlformats.org/officeDocument/2006/relationships" xmlns:p="http://schemas.openxmlformats.org/presentationml/2006/main">
+  <p:cSld name="Slide 7">
+    <p:bg>
+      <p:bgPr>
+        <a:solidFill>
+          <a:srgbClr val="000000"/>
+        </a:solidFill>
+      </p:bgPr>
+    </p:bg>
+    <p:spTree>
+      <p:nvGrpSpPr>
+        <p:cNvPr id="1" name=""/>
+        <p:cNvGrpSpPr/>
+        <p:nvPr/>
+      </p:nvGrpSpPr>
+      <p:grpSpPr>
+        <a:xfrm>
+          <a:off x="0" y="0"/>
+          <a:ext cx="0" cy="0"/>
+          <a:chOff x="0" y="0"/>
+          <a:chExt cx="0" cy="0"/>
+        </a:xfrm>
+      </p:grpSpPr>
+      <p:sp>
+        <p:nvSpPr>
+          <p:cNvPr id="2" name="Text 0"/>
+          <p:cNvSpPr txBox="1"/>
+          <p:nvPr/>
+        </p:nvSpPr>
+        <p:spPr>
+          <a:xfrm>
+            <a:off x="548640" y="457200"/>
+            <a:ext cx="11064240" cy="5943600"/>
+          </a:xfrm>
+          <a:prstGeom prst="rect">
+            <a:avLst/>
+          </a:prstGeom>
+          <a:noFill/>
+          <a:ln/>
+        </p:spPr>
+        <p:txBody>
+          <a:bodyPr wrap="square" lIns="0" tIns="0" rIns="0" bIns="0" rtlCol="0" anchor="ctr"/>
+          <a:lstStyle/>
+          <a:p>
+            <a:pPr algn="ctr" indent="0" marL="0">
+              <a:buNone/>
+            </a:pPr>
+            <a:r>
+              <a:rPr lang="en-US" sz="4800" b="1" i="1" dirty="0">
                 <a:solidFill>
                   <a:srgbClr val="FFFFFF"/>
                 </a:solidFill>
@@ -1965,14 +2125,14 @@
               </a:rPr>
               <a:t>Ти розвеселив душу мою,</a:t>
             </a:r>
-            <a:endParaRPr lang="en-US" sz="4000" dirty="0"/>
+            <a:endParaRPr lang="en-US" sz="4800" dirty="0"/>
           </a:p>
           <a:p>
             <a:pPr algn="ctr" indent="0" marL="0">
               <a:buNone/>
             </a:pPr>
             <a:r>
-              <a:rPr lang="en-US" sz="4000" b="1" i="1" dirty="0">
+              <a:rPr lang="en-US" sz="4800" b="1" i="1" dirty="0">
                 <a:solidFill>
                   <a:srgbClr val="FFFFFF"/>
                 </a:solidFill>
@@ -1982,14 +2142,14 @@
               </a:rPr>
               <a:t>Я Тобі Господь хвалу даю</a:t>
             </a:r>
-            <a:endParaRPr lang="en-US" sz="4000" dirty="0"/>
+            <a:endParaRPr lang="en-US" sz="4800" dirty="0"/>
           </a:p>
           <a:p>
             <a:pPr algn="ctr" indent="0" marL="0">
               <a:buNone/>
             </a:pPr>
             <a:r>
-              <a:rPr lang="en-US" sz="4000" b="1" i="1" dirty="0">
+              <a:rPr lang="en-US" sz="4800" b="1" i="1" dirty="0">
                 <a:solidFill>
                   <a:srgbClr val="FFFFFF"/>
                 </a:solidFill>
@@ -1999,14 +2159,14 @@
               </a:rPr>
               <a:t>Діла Твої великі, мій Отець,</a:t>
             </a:r>
-            <a:endParaRPr lang="en-US" sz="4000" dirty="0"/>
+            <a:endParaRPr lang="en-US" sz="4800" dirty="0"/>
           </a:p>
           <a:p>
             <a:pPr algn="ctr" indent="0" marL="0">
               <a:buNone/>
             </a:pPr>
             <a:r>
-              <a:rPr lang="en-US" sz="4000" b="1" i="1" dirty="0">
+              <a:rPr lang="en-US" sz="4800" b="1" i="1" dirty="0">
                 <a:solidFill>
                   <a:srgbClr val="FFFFFF"/>
                 </a:solidFill>
@@ -2016,14 +2176,14 @@
               </a:rPr>
               <a:t>Ти - мій Творець (Ти - мій Творець)</a:t>
             </a:r>
-            <a:endParaRPr lang="en-US" sz="4000" dirty="0"/>
+            <a:endParaRPr lang="en-US" sz="4800" dirty="0"/>
           </a:p>
           <a:p>
             <a:pPr algn="ctr" indent="0" marL="0">
               <a:buNone/>
             </a:pPr>
             <a:r>
-              <a:rPr lang="en-US" sz="4000" b="1" i="1" dirty="0">
+              <a:rPr lang="en-US" sz="4800" b="1" i="1" dirty="0">
                 <a:solidFill>
                   <a:srgbClr val="FFFFFF"/>
                 </a:solidFill>
@@ -2033,7 +2193,7 @@
               </a:rPr>
               <a:t>***</a:t>
             </a:r>
-            <a:endParaRPr lang="en-US" sz="4000" dirty="0"/>
+            <a:endParaRPr lang="en-US" sz="4800" dirty="0"/>
           </a:p>
         </p:txBody>
       </p:sp>

</xml_diff>

<commit_message>
Update PowerPoint for song #3 in FUBC - Українські
</commit_message>
<xml_diff>
--- a/fubc-ua/3-Благо Cлавити Господа.pptx
+++ b/fubc-ua/3-Благо Cлавити Господа.pptx
@@ -12,9 +12,10 @@
     <p:sldId id="260" r:id="rId6"/>
     <p:sldId id="261" r:id="rId7"/>
     <p:sldId id="262" r:id="rId8"/>
+    <p:sldId id="263" r:id="rId9"/>
   </p:sldIdLst>
   <p:notesMasterIdLst>
-    <p:notesMasterId r:id="rId9"/>
+    <p:notesMasterId r:id="rId10"/>
   </p:notesMasterIdLst>
   <p:sldSz cx="12192000" cy="6858000"/>
   <p:notesSz cx="6858000" cy="12192000"/>
@@ -1060,6 +1061,94 @@
             <a:fld id="{F7021451-1387-4CA6-816F-3879F97B5CBC}" type="slidenum">
               <a:rPr lang="en-US"/>
               <a:t>7</a:t>
+            </a:fld>
+            <a:endParaRPr lang="en-US"/>
+          </a:p>
+        </p:txBody>
+      </p:sp>
+    </p:spTree>
+    <p:extLst>
+      <p:ext uri="{BB962C8B-B14F-4D97-AF65-F5344CB8AC3E}">
+        <p14:creationId xmlns:p14="http://schemas.microsoft.com/office/powerpoint/2010/main" val="1024086991"/>
+      </p:ext>
+    </p:extLst>
+  </p:cSld>
+  <p:clrMapOvr>
+    <a:masterClrMapping/>
+  </p:clrMapOvr>
+</p:notes>
+</file>
+
+<file path=ppt/notesSlides/notesSlide8.xml><?xml version="1.0" encoding="utf-8"?>
+<p:notes xmlns:a="http://schemas.openxmlformats.org/drawingml/2006/main" xmlns:r="http://schemas.openxmlformats.org/officeDocument/2006/relationships" xmlns:p="http://schemas.openxmlformats.org/presentationml/2006/main">
+  <p:cSld>
+    <p:spTree>
+      <p:nvGrpSpPr>
+        <p:cNvPr id="1" name=""/>
+        <p:cNvGrpSpPr/>
+        <p:nvPr/>
+      </p:nvGrpSpPr>
+      <p:grpSpPr>
+        <a:xfrm>
+          <a:off x="0" y="0"/>
+          <a:ext cx="0" cy="0"/>
+          <a:chOff x="0" y="0"/>
+          <a:chExt cx="0" cy="0"/>
+        </a:xfrm>
+      </p:grpSpPr>
+      <p:sp>
+        <p:nvSpPr>
+          <p:cNvPr id="2" name="Slide Image Placeholder 1"/>
+          <p:cNvSpPr>
+            <a:spLocks noGrp="1" noRot="1" noChangeAspect="1"/>
+          </p:cNvSpPr>
+          <p:nvPr>
+            <p:ph type="sldImg"/>
+          </p:nvPr>
+        </p:nvSpPr>
+        <p:spPr/>
+      </p:sp>
+      <p:sp>
+        <p:nvSpPr>
+          <p:cNvPr id="3" name="Notes Placeholder 2"/>
+          <p:cNvSpPr>
+            <a:spLocks noGrp="1"/>
+          </p:cNvSpPr>
+          <p:nvPr>
+            <p:ph type="body" idx="1"/>
+          </p:nvPr>
+        </p:nvSpPr>
+        <p:spPr/>
+        <p:txBody>
+          <a:bodyPr/>
+          <a:lstStyle/>
+          <a:p>
+            <a:r>
+              <a:rPr lang="en-US" dirty="0"/>
+              <a:t/>
+            </a:r>
+            <a:endParaRPr lang="en-US" dirty="0"/>
+          </a:p>
+        </p:txBody>
+      </p:sp>
+      <p:sp>
+        <p:nvSpPr>
+          <p:cNvPr id="4" name="Slide Number Placeholder 3"/>
+          <p:cNvSpPr>
+            <a:spLocks noGrp="1"/>
+          </p:cNvSpPr>
+          <p:nvPr>
+            <p:ph type="sldNum" sz="quarter" idx="10"/>
+          </p:nvPr>
+        </p:nvSpPr>
+        <p:spPr/>
+        <p:txBody>
+          <a:bodyPr/>
+          <a:lstStyle/>
+          <a:p>
+            <a:fld id="{F7021451-1387-4CA6-816F-3879F97B5CBC}" type="slidenum">
+              <a:rPr lang="en-US"/>
+              <a:t>8</a:t>
             </a:fld>
             <a:endParaRPr lang="en-US"/>
           </a:p>
@@ -1530,7 +1619,7 @@
                 <a:ea typeface="Arial" pitchFamily="34" charset="-122"/>
                 <a:cs typeface="Arial" pitchFamily="34" charset="-120"/>
               </a:rPr>
-              <a:t>оспівувати Твоє Ім'я</a:t>
+              <a:t>оспівувати Твоє Ім'я.</a:t>
             </a:r>
             <a:endParaRPr lang="en-US" sz="4800" dirty="0"/>
           </a:p>
@@ -1652,7 +1741,7 @@
                 <a:ea typeface="Arial" pitchFamily="34" charset="-122"/>
                 <a:cs typeface="Arial" pitchFamily="34" charset="-120"/>
               </a:rPr>
-              <a:t>Я Тобі Господь хвалу даю</a:t>
+              <a:t>Я Тобі Господь хвалу даю.</a:t>
             </a:r>
             <a:endParaRPr lang="en-US" sz="4800" dirty="0"/>
           </a:p>
@@ -1686,7 +1775,7 @@
                 <a:ea typeface="Arial" pitchFamily="34" charset="-122"/>
                 <a:cs typeface="Arial" pitchFamily="34" charset="-120"/>
               </a:rPr>
-              <a:t>Ти - мій Творець (Ти - мій Творець)</a:t>
+              <a:t>Ти - мій Творець.</a:t>
             </a:r>
             <a:endParaRPr lang="en-US" sz="4800" dirty="0"/>
           </a:p>
@@ -1791,7 +1880,7 @@
                 <a:ea typeface="Arial" pitchFamily="34" charset="-122"/>
                 <a:cs typeface="Arial" pitchFamily="34" charset="-120"/>
               </a:rPr>
-              <a:t>Знаю я - Ти Господь Святий ,</a:t>
+              <a:t>Знаю я - Ти Господь Святий,</a:t>
             </a:r>
             <a:endParaRPr lang="en-US" sz="4800" dirty="0"/>
           </a:p>
@@ -1896,7 +1985,7 @@
                 <a:ea typeface="Arial" pitchFamily="34" charset="-122"/>
                 <a:cs typeface="Arial" pitchFamily="34" charset="-120"/>
               </a:rPr>
-              <a:t>Я Тобі Господь хвалу даю</a:t>
+              <a:t>Я Тобі Господь хвалу даю.</a:t>
             </a:r>
             <a:endParaRPr lang="en-US" sz="4800" dirty="0"/>
           </a:p>
@@ -1930,7 +2019,7 @@
                 <a:ea typeface="Arial" pitchFamily="34" charset="-122"/>
                 <a:cs typeface="Arial" pitchFamily="34" charset="-120"/>
               </a:rPr>
-              <a:t>Ти - мій Творець (Ти - мій Творець)</a:t>
+              <a:t>Ти - мій Творець.</a:t>
             </a:r>
             <a:endParaRPr lang="en-US" sz="4800" dirty="0"/>
           </a:p>
@@ -2140,7 +2229,7 @@
                 <a:ea typeface="Arial" pitchFamily="34" charset="-122"/>
                 <a:cs typeface="Arial" pitchFamily="34" charset="-120"/>
               </a:rPr>
-              <a:t>Я Тобі Господь хвалу даю</a:t>
+              <a:t>Я Тобі Господь хвалу даю.</a:t>
             </a:r>
             <a:endParaRPr lang="en-US" sz="4800" dirty="0"/>
           </a:p>
@@ -2174,8 +2263,14 @@
                 <a:ea typeface="Arial" pitchFamily="34" charset="-122"/>
                 <a:cs typeface="Arial" pitchFamily="34" charset="-120"/>
               </a:rPr>
-              <a:t>Ти - мій Творець (Ти - мій Творець)</a:t>
-            </a:r>
+              <a:t>Ти - мій Творець</a:t>
+            </a:r>
+            <a:endParaRPr lang="en-US" sz="4800" dirty="0"/>
+          </a:p>
+          <a:p>
+            <a:pPr algn="ctr" indent="0" marL="0">
+              <a:buNone/>
+            </a:pPr>
             <a:endParaRPr lang="en-US" sz="4800" dirty="0"/>
           </a:p>
           <a:p>
@@ -2197,6 +2292,38 @@
           </a:p>
         </p:txBody>
       </p:sp>
+    </p:spTree>
+  </p:cSld>
+  <p:clrMapOvr>
+    <a:masterClrMapping/>
+  </p:clrMapOvr>
+</p:sld>
+</file>
+
+<file path=ppt/slides/slide8.xml><?xml version="1.0" encoding="utf-8"?>
+<p:sld xmlns:a="http://schemas.openxmlformats.org/drawingml/2006/main" xmlns:r="http://schemas.openxmlformats.org/officeDocument/2006/relationships" xmlns:p="http://schemas.openxmlformats.org/presentationml/2006/main">
+  <p:cSld name="Slide 8">
+    <p:bg>
+      <p:bgPr>
+        <a:solidFill>
+          <a:srgbClr val="000000"/>
+        </a:solidFill>
+      </p:bgPr>
+    </p:bg>
+    <p:spTree>
+      <p:nvGrpSpPr>
+        <p:cNvPr id="1" name=""/>
+        <p:cNvGrpSpPr/>
+        <p:nvPr/>
+      </p:nvGrpSpPr>
+      <p:grpSpPr>
+        <a:xfrm>
+          <a:off x="0" y="0"/>
+          <a:ext cx="0" cy="0"/>
+          <a:chOff x="0" y="0"/>
+          <a:chExt cx="0" cy="0"/>
+        </a:xfrm>
+      </p:grpSpPr>
     </p:spTree>
   </p:cSld>
   <p:clrMapOvr>

</xml_diff>